<commit_message>
docs: GitHub link in README and presentation
Co-Authored-By: Claude Opus 5.5 <noreply@anthropic.com>
</commit_message>
<xml_diff>
--- a/presentation/Prezentare_Semne_Circulatie.pptx
+++ b/presentation/Prezentare_Semne_Circulatie.pptx
@@ -124,19 +124,19 @@
   <p:extLst>
     <p:ext uri="{521415D9-36F7-43E2-AB2F-B90AF26B5E84}">
       <p14:sectionLst xmlns:p14="http://schemas.microsoft.com/office/powerpoint/2010/main">
-        <p14:section name="Introducere" id="{1472edc3-58ec-7178-bf03-6bd3851c9181}">
+        <p14:section name="Introducere" id="{5b88b2d0-fa33-30c1-3ea7-3904dad70e7e}">
           <p14:sldIdLst>
             <p14:sldId id="256"/>
             <p14:sldId id="257"/>
           </p14:sldIdLst>
         </p14:section>
-        <p14:section name="Datele" id="{cfa6fd34-f99d-318a-3931-479901394915}">
+        <p14:section name="Datele" id="{54e53f08-1afb-fff5-ee63-8c5669bf055f}">
           <p14:sldIdLst>
             <p14:sldId id="258"/>
             <p14:sldId id="259"/>
           </p14:sldIdLst>
         </p14:section>
-        <p14:section name="Arhitectura proprie" id="{33fd9d2b-e4e1-76f2-ef39-56828cf873a8}">
+        <p14:section name="Arhitectura proprie" id="{1a14771d-69e8-0d57-ece1-93cc052a0724}">
           <p14:sldIdLst>
             <p14:sldId id="260"/>
             <p14:sldId id="261"/>
@@ -148,19 +148,19 @@
             <p14:sldId id="267"/>
           </p14:sldIdLst>
         </p14:section>
-        <p14:section name="ResNet50 și comparația" id="{ba74357c-789f-8832-dccd-4b9fdf741dd8}">
+        <p14:section name="ResNet50 și comparația" id="{17c12860-0309-2b53-b7e8-d119e932e13b}">
           <p14:sldIdLst>
             <p14:sldId id="268"/>
             <p14:sldId id="269"/>
             <p14:sldId id="270"/>
           </p14:sldIdLst>
         </p14:section>
-        <p14:section name="Aplicația" id="{4b87c803-713f-c23a-1208-43eae9634156}">
+        <p14:section name="Aplicația" id="{bf28250d-2f30-ffa5-c184-c5a146908406}">
           <p14:sldIdLst>
             <p14:sldId id="271"/>
           </p14:sldIdLst>
         </p14:section>
-        <p14:section name="Final" id="{3a5f9e7d-a7aa-42ac-4106-ad524a9310ff}">
+        <p14:section name="Final" id="{df8afb1c-7a31-b0a5-a4d3-ffc0e440a57d}">
           <p14:sldIdLst>
             <p14:sldId id="272"/>
             <p14:sldId id="273"/>
@@ -5203,12 +5203,19 @@
               <a:buNone/>
             </a:pPr>
             <a:r>
-              <a:rPr lang="en-US" sz="1600" dirty="0">
-                <a:solidFill>
-                  <a:schemeClr val="accent5"/>
-                </a:solidFill>
-              </a:rPr>
-              <a:t>[link GitHub]</a:t>
+              <a:rPr lang="en-US" sz="1600" u="sng" dirty="0">
+                <a:solidFill>
+                  <a:schemeClr val="bg1"/>
+                </a:solidFill>
+                <a:hlinkClick r:id="rId1" invalidUrl="" action="" tgtFrame="" tooltip="" history="1" highlightClick="0" endSnd="0">
+                  <a:extLst>
+                    <a:ext uri="{A12FA001-AC4F-418D-AE19-62706E023703}">
+                      <ahyp:hlinkClr xmlns:ahyp="http://schemas.microsoft.com/office/drawing/2018/hyperlinkcolor" val="tx"/>
+                    </a:ext>
+                  </a:extLst>
+                </a:hlinkClick>
+              </a:rPr>
+              <a:t>github.com/GalanIonut/traffic-sign-recognition</a:t>
             </a:r>
             <a:endParaRPr lang="en-US" sz="1600" dirty="0"/>
           </a:p>
@@ -5223,7 +5230,7 @@
           <p:nvPr/>
         </p:nvPicPr>
         <p:blipFill>
-          <a:blip r:embed="rId1"/>
+          <a:blip r:embed="rId2"/>
           <a:stretch>
             <a:fillRect/>
           </a:stretch>

</xml_diff>

<commit_message>
docs: team members in README and presentation
Co-Authored-By: Claude Opus 5.5 <noreply@anthropic.com>
</commit_message>
<xml_diff>
--- a/presentation/Prezentare_Semne_Circulatie.pptx
+++ b/presentation/Prezentare_Semne_Circulatie.pptx
@@ -124,19 +124,19 @@
   <p:extLst>
     <p:ext uri="{521415D9-36F7-43E2-AB2F-B90AF26B5E84}">
       <p14:sectionLst xmlns:p14="http://schemas.microsoft.com/office/powerpoint/2010/main">
-        <p14:section name="Introducere" id="{5b88b2d0-fa33-30c1-3ea7-3904dad70e7e}">
+        <p14:section name="Introducere" id="{6cb60fef-577a-7356-1fc4-c967da3bdca5}">
           <p14:sldIdLst>
             <p14:sldId id="256"/>
             <p14:sldId id="257"/>
           </p14:sldIdLst>
         </p14:section>
-        <p14:section name="Datele" id="{54e53f08-1afb-fff5-ee63-8c5669bf055f}">
+        <p14:section name="Datele" id="{60efe91d-71b8-5820-d544-e3b13063f1b7}">
           <p14:sldIdLst>
             <p14:sldId id="258"/>
             <p14:sldId id="259"/>
           </p14:sldIdLst>
         </p14:section>
-        <p14:section name="Arhitectura proprie" id="{1a14771d-69e8-0d57-ece1-93cc052a0724}">
+        <p14:section name="Arhitectura proprie" id="{74394bb1-7564-0297-383e-4d85bff9baac}">
           <p14:sldIdLst>
             <p14:sldId id="260"/>
             <p14:sldId id="261"/>
@@ -148,19 +148,19 @@
             <p14:sldId id="267"/>
           </p14:sldIdLst>
         </p14:section>
-        <p14:section name="ResNet50 și comparația" id="{17c12860-0309-2b53-b7e8-d119e932e13b}">
+        <p14:section name="ResNet50 și comparația" id="{f0d4d857-3f4f-abda-5008-c72f157a79a5}">
           <p14:sldIdLst>
             <p14:sldId id="268"/>
             <p14:sldId id="269"/>
             <p14:sldId id="270"/>
           </p14:sldIdLst>
         </p14:section>
-        <p14:section name="Aplicația" id="{bf28250d-2f30-ffa5-c184-c5a146908406}">
+        <p14:section name="Aplicația" id="{fedc4f1b-fc08-79ee-e316-48c044344ded}">
           <p14:sldIdLst>
             <p14:sldId id="271"/>
           </p14:sldIdLst>
         </p14:section>
-        <p14:section name="Final" id="{df8afb1c-7a31-b0a5-a4d3-ffc0e440a57d}">
+        <p14:section name="Final" id="{26e4a090-ecad-f972-5429-7b5e4047d8df}">
           <p14:sldIdLst>
             <p14:sldId id="272"/>
             <p14:sldId id="273"/>
@@ -2906,7 +2906,21 @@
                   <a:schemeClr val="accent5"/>
                 </a:solidFill>
               </a:rPr>
-              <a:t>Tehnici de Inteligență Artificială · Echipa: [nume 1], [nume 2], [nume 3]</a:t>
+              <a:t>Tehnici de Inteligență Artificială</a:t>
+            </a:r>
+            <a:endParaRPr lang="en-US" sz="1600" dirty="0"/>
+          </a:p>
+          <a:p>
+            <a:pPr algn="l" indent="0" marL="0">
+              <a:buNone/>
+            </a:pPr>
+            <a:r>
+              <a:rPr lang="en-US" sz="1600" dirty="0">
+                <a:solidFill>
+                  <a:schemeClr val="accent5"/>
+                </a:solidFill>
+              </a:rPr>
+              <a:t>Echipa: Galan Ionuț-Cătălin, Cioponea Ionuț-Sebastian, Braitor Ana-Maria</a:t>
             </a:r>
             <a:endParaRPr lang="en-US" sz="1600" dirty="0"/>
           </a:p>

</xml_diff>